<commit_message>
Add Mass PowerPoint background support
</commit_message>
<xml_diff>
--- a/Storage/PowerPointTemplates/Template.pptx
+++ b/Storage/PowerPointTemplates/Template.pptx
@@ -466,8 +466,16 @@
 </file>
 
 <file path=ppt/slideLayouts/slideLayout1.xml><?xml version="1.0" encoding="utf-8"?>
-<p:sldLayout xmlns:a="http://schemas.openxmlformats.org/drawingml/2006/main" xmlns:r="http://schemas.openxmlformats.org/officeDocument/2006/relationships" xmlns:p="http://schemas.openxmlformats.org/presentationml/2006/main" type="title" preserve="1">
+<p:sldLayout xmlns:a="http://schemas.openxmlformats.org/drawingml/2006/main" xmlns:r="http://schemas.openxmlformats.org/officeDocument/2006/relationships" xmlns:p="http://schemas.openxmlformats.org/presentationml/2006/main" preserve="1" userDrawn="1">
   <p:cSld name="Title">
+    <p:bg>
+      <p:bgPr>
+        <a:solidFill>
+          <a:schemeClr val="bg1"/>
+        </a:solidFill>
+        <a:effectLst/>
+      </p:bgPr>
+    </p:bg>
     <p:spTree>
       <p:nvGrpSpPr>
         <p:cNvPr id="1" name=""/>
@@ -517,7 +525,10 @@
           <a:lstStyle>
             <a:lvl1pPr marL="0" indent="0" algn="ctr">
               <a:buNone/>
-              <a:defRPr sz="2400" b="0" i="1">
+              <a:defRPr sz="1800" b="0" i="1">
+                <a:solidFill>
+                  <a:schemeClr val="accent1"/>
+                </a:solidFill>
                 <a:latin typeface="Times New Roman" panose="02020603050405020304" pitchFamily="18" charset="0"/>
                 <a:cs typeface="Times New Roman" panose="02020603050405020304" pitchFamily="18" charset="0"/>
               </a:defRPr>
@@ -557,7 +568,7 @@
           </a:lstStyle>
           <a:p>
             <a:r>
-              <a:rPr lang="en-US"/>
+              <a:rPr lang="en-US" dirty="0"/>
               <a:t>Click to edit Master subtitle style</a:t>
             </a:r>
             <a:endParaRPr lang="en-AE" dirty="0"/>
@@ -609,9 +620,54 @@
           </a:lstStyle>
           <a:p>
             <a:r>
-              <a:rPr lang="en-US"/>
+              <a:rPr lang="en-US" dirty="0"/>
               <a:t>Click to edit Master title style</a:t>
             </a:r>
+            <a:endParaRPr lang="en-AE" dirty="0"/>
+          </a:p>
+        </p:txBody>
+      </p:sp>
+      <p:sp>
+        <p:nvSpPr>
+          <p:cNvPr id="6" name="Date">
+            <a:extLst>
+              <a:ext uri="{FF2B5EF4-FFF2-40B4-BE49-F238E27FC236}">
+                <a16:creationId xmlns:a16="http://schemas.microsoft.com/office/drawing/2014/main" id="{1834E721-FFC6-71BA-0416-FB18DF078827}"/>
+              </a:ext>
+            </a:extLst>
+          </p:cNvPr>
+          <p:cNvSpPr>
+            <a:spLocks noGrp="1"/>
+          </p:cNvSpPr>
+          <p:nvPr>
+            <p:ph type="body" sz="quarter" idx="10"/>
+          </p:nvPr>
+        </p:nvSpPr>
+        <p:spPr>
+          <a:xfrm>
+            <a:off x="0" y="3219450"/>
+            <a:ext cx="12192000" cy="419100"/>
+          </a:xfrm>
+          <a:prstGeom prst="rect">
+            <a:avLst/>
+          </a:prstGeom>
+        </p:spPr>
+        <p:txBody>
+          <a:bodyPr/>
+          <a:lstStyle>
+            <a:lvl1pPr algn="ctr">
+              <a:buNone/>
+              <a:defRPr sz="1800">
+                <a:solidFill>
+                  <a:schemeClr val="accent1"/>
+                </a:solidFill>
+                <a:latin typeface="Times New Roman" panose="02020603050405020304" pitchFamily="18" charset="0"/>
+                <a:cs typeface="Times New Roman" panose="02020603050405020304" pitchFamily="18" charset="0"/>
+              </a:defRPr>
+            </a:lvl1pPr>
+          </a:lstStyle>
+          <a:p>
+            <a:pPr lvl="0"/>
             <a:endParaRPr lang="en-AE" dirty="0"/>
           </a:p>
         </p:txBody>
@@ -644,6 +700,14 @@
 <file path=ppt/slideLayouts/slideLayout2.xml><?xml version="1.0" encoding="utf-8"?>
 <p:sldLayout xmlns:a="http://schemas.openxmlformats.org/drawingml/2006/main" xmlns:r="http://schemas.openxmlformats.org/officeDocument/2006/relationships" xmlns:p="http://schemas.openxmlformats.org/presentationml/2006/main" preserve="1" userDrawn="1">
   <p:cSld name="Song - Title + Lyrics">
+    <p:bg>
+      <p:bgPr>
+        <a:solidFill>
+          <a:schemeClr val="bg1"/>
+        </a:solidFill>
+        <a:effectLst/>
+      </p:bgPr>
+    </p:bg>
     <p:spTree>
       <p:nvGrpSpPr>
         <p:cNvPr id="1" name=""/>
@@ -938,7 +1002,7 @@
 </file>
 
 <file path=ppt/slideLayouts/slideLayout4.xml><?xml version="1.0" encoding="utf-8"?>
-<p:sldLayout xmlns:a="http://schemas.openxmlformats.org/drawingml/2006/main" xmlns:r="http://schemas.openxmlformats.org/officeDocument/2006/relationships" xmlns:p="http://schemas.openxmlformats.org/presentationml/2006/main" preserve="1">
+<p:sldLayout xmlns:a="http://schemas.openxmlformats.org/drawingml/2006/main" xmlns:r="http://schemas.openxmlformats.org/officeDocument/2006/relationships" xmlns:p="http://schemas.openxmlformats.org/presentationml/2006/main" preserve="1" userDrawn="1">
   <p:cSld name="Divider">
     <p:spTree>
       <p:nvGrpSpPr>
@@ -1373,10 +1437,10 @@
         </p:nvSpPr>
         <p:spPr/>
         <p:txBody>
-          <a:bodyPr/>
+          <a:bodyPr anchor="ctr"/>
           <a:lstStyle/>
           <a:p>
-            <a:endParaRPr lang="en-AE"/>
+            <a:endParaRPr lang="en-AE" sz="1800" dirty="0"/>
           </a:p>
         </p:txBody>
       </p:sp>

</xml_diff>

<commit_message>
Add presentation library and unified Mass plan
</commit_message>
<xml_diff>
--- a/Storage/PowerPointTemplates/Template.pptx
+++ b/Storage/PowerPointTemplates/Template.pptx
@@ -1003,6 +1003,265 @@
 
 <file path=ppt/slideLayouts/slideLayout4.xml><?xml version="1.0" encoding="utf-8"?>
 <p:sldLayout xmlns:a="http://schemas.openxmlformats.org/drawingml/2006/main" xmlns:r="http://schemas.openxmlformats.org/officeDocument/2006/relationships" xmlns:p="http://schemas.openxmlformats.org/presentationml/2006/main" preserve="1" userDrawn="1">
+  <p:cSld name="Presentation - Title + Text">
+    <p:bg>
+      <p:bgPr>
+        <a:solidFill>
+          <a:schemeClr val="bg1"/>
+        </a:solidFill>
+        <a:effectLst/>
+      </p:bgPr>
+    </p:bg>
+    <p:spTree>
+      <p:nvGrpSpPr>
+        <p:cNvPr id="1" name=""/>
+        <p:cNvGrpSpPr/>
+        <p:nvPr/>
+      </p:nvGrpSpPr>
+      <p:grpSpPr>
+        <a:xfrm>
+          <a:off x="0" y="0"/>
+          <a:ext cx="0" cy="0"/>
+          <a:chOff x="0" y="0"/>
+          <a:chExt cx="0" cy="0"/>
+        </a:xfrm>
+      </p:grpSpPr>
+      <p:sp>
+        <p:nvSpPr>
+          <p:cNvPr id="11" name="Text">
+            <a:extLst>
+              <a:ext uri="{FF2B5EF4-FFF2-40B4-BE49-F238E27FC236}">
+                <a16:creationId xmlns:a16="http://schemas.microsoft.com/office/drawing/2014/main" id="{CEF82248-E6A0-7DCA-2366-B58D4E0F4D09}"/>
+              </a:ext>
+            </a:extLst>
+          </p:cNvPr>
+          <p:cNvSpPr>
+            <a:spLocks noGrp="1"/>
+          </p:cNvSpPr>
+          <p:nvPr>
+            <p:ph type="body" sz="quarter" idx="10"/>
+          </p:nvPr>
+        </p:nvSpPr>
+        <p:spPr>
+          <a:xfrm>
+            <a:off x="0" y="1325564"/>
+            <a:ext cx="12192000" cy="5532436"/>
+          </a:xfrm>
+          <a:prstGeom prst="rect">
+            <a:avLst/>
+          </a:prstGeom>
+        </p:spPr>
+        <p:txBody>
+          <a:bodyPr anchor="ctr">
+            <a:normAutofit/>
+          </a:bodyPr>
+          <a:lstStyle>
+            <a:lvl1pPr marL="0" indent="0" algn="ctr">
+              <a:lnSpc>
+                <a:spcPct val="100000"/>
+              </a:lnSpc>
+              <a:spcBef>
+                <a:spcPts val="0"/>
+              </a:spcBef>
+              <a:buNone/>
+              <a:defRPr sz="5200" b="1">
+                <a:latin typeface="Times New Roman" panose="02020603050405020304" pitchFamily="18" charset="0"/>
+                <a:ea typeface="Verdana" panose="020B0604030504040204" pitchFamily="34" charset="0"/>
+                <a:cs typeface="Times New Roman" panose="02020603050405020304" pitchFamily="18" charset="0"/>
+              </a:defRPr>
+            </a:lvl1pPr>
+          </a:lstStyle>
+          <a:p>
+            <a:pPr lvl="0"/>
+            <a:r>
+              <a:rPr lang="en-US" dirty="0"/>
+              <a:t>Click to edit Master text styles</a:t>
+            </a:r>
+          </a:p>
+        </p:txBody>
+      </p:sp>
+      <p:sp>
+        <p:nvSpPr>
+          <p:cNvPr id="2" name="Title">
+            <a:extLst>
+              <a:ext uri="{FF2B5EF4-FFF2-40B4-BE49-F238E27FC236}">
+                <a16:creationId xmlns:a16="http://schemas.microsoft.com/office/drawing/2014/main" id="{D8236168-AA03-815A-E2FA-4A05B896B841}"/>
+              </a:ext>
+            </a:extLst>
+          </p:cNvPr>
+          <p:cNvSpPr>
+            <a:spLocks noGrp="1"/>
+          </p:cNvSpPr>
+          <p:nvPr>
+            <p:ph type="title"/>
+          </p:nvPr>
+        </p:nvSpPr>
+        <p:spPr>
+          <a:xfrm>
+            <a:off x="0" y="0"/>
+            <a:ext cx="12192000" cy="1325563"/>
+          </a:xfrm>
+          <a:prstGeom prst="rect">
+            <a:avLst/>
+          </a:prstGeom>
+        </p:spPr>
+        <p:txBody>
+          <a:bodyPr anchor="ctr">
+            <a:normAutofit/>
+          </a:bodyPr>
+          <a:lstStyle>
+            <a:lvl1pPr algn="ctr">
+              <a:defRPr sz="6000" b="1">
+                <a:solidFill>
+                  <a:schemeClr val="accent1"/>
+                </a:solidFill>
+                <a:latin typeface="Times New Roman" panose="02020603050405020304" pitchFamily="18" charset="0"/>
+                <a:ea typeface="Verdana" panose="020B0604030504040204" pitchFamily="34" charset="0"/>
+                <a:cs typeface="Times New Roman" panose="02020603050405020304" pitchFamily="18" charset="0"/>
+              </a:defRPr>
+            </a:lvl1pPr>
+          </a:lstStyle>
+          <a:p>
+            <a:r>
+              <a:rPr lang="en-US" dirty="0"/>
+              <a:t>Click to edit Master title style</a:t>
+            </a:r>
+            <a:endParaRPr lang="en-AE" dirty="0"/>
+          </a:p>
+        </p:txBody>
+      </p:sp>
+    </p:spTree>
+    <p:extLst>
+      <p:ext uri="{BB962C8B-B14F-4D97-AF65-F5344CB8AC3E}">
+        <p14:creationId xmlns:p14="http://schemas.microsoft.com/office/powerpoint/2010/main" val="3531721652"/>
+      </p:ext>
+    </p:extLst>
+  </p:cSld>
+  <p:clrMapOvr>
+    <a:masterClrMapping/>
+  </p:clrMapOvr>
+  <mc:AlternateContent xmlns:mc="http://schemas.openxmlformats.org/markup-compatibility/2006" xmlns:p14="http://schemas.microsoft.com/office/powerpoint/2010/main">
+    <mc:Choice Requires="p14">
+      <p:transition spd="med" p14:dur="700">
+        <p:fade/>
+      </p:transition>
+    </mc:Choice>
+    <mc:Fallback xmlns="">
+      <p:transition spd="med">
+        <p:fade/>
+      </p:transition>
+    </mc:Fallback>
+  </mc:AlternateContent>
+  <p:extLst>
+    <p:ext uri="{DCECCB84-F9BA-43D5-87BE-67443E8EF086}">
+      <p15:sldGuideLst xmlns:p15="http://schemas.microsoft.com/office/powerpoint/2012/main">
+        <p15:guide id="1" orient="horz" pos="2160" userDrawn="1">
+          <p15:clr>
+            <a:srgbClr val="FBAE40"/>
+          </p15:clr>
+        </p15:guide>
+        <p15:guide id="2" pos="3840" userDrawn="1">
+          <p15:clr>
+            <a:srgbClr val="FBAE40"/>
+          </p15:clr>
+        </p15:guide>
+      </p15:sldGuideLst>
+    </p:ext>
+  </p:extLst>
+</p:sldLayout>
+</file>
+
+<file path=ppt/slideLayouts/slideLayout5.xml><?xml version="1.0" encoding="utf-8"?>
+<p:sldLayout xmlns:a="http://schemas.openxmlformats.org/drawingml/2006/main" xmlns:r="http://schemas.openxmlformats.org/officeDocument/2006/relationships" xmlns:p="http://schemas.openxmlformats.org/presentationml/2006/main" preserve="1">
+  <p:cSld name="Presentation - Text">
+    <p:spTree>
+      <p:nvGrpSpPr>
+        <p:cNvPr id="1" name=""/>
+        <p:cNvGrpSpPr/>
+        <p:nvPr/>
+      </p:nvGrpSpPr>
+      <p:grpSpPr>
+        <a:xfrm>
+          <a:off x="0" y="0"/>
+          <a:ext cx="0" cy="0"/>
+          <a:chOff x="0" y="0"/>
+          <a:chExt cx="0" cy="0"/>
+        </a:xfrm>
+      </p:grpSpPr>
+      <p:sp>
+        <p:nvSpPr>
+          <p:cNvPr id="11" name="Text">
+            <a:extLst>
+              <a:ext uri="{FF2B5EF4-FFF2-40B4-BE49-F238E27FC236}">
+                <a16:creationId xmlns:a16="http://schemas.microsoft.com/office/drawing/2014/main" id="{CEF82248-E6A0-7DCA-2366-B58D4E0F4D09}"/>
+              </a:ext>
+            </a:extLst>
+          </p:cNvPr>
+          <p:cNvSpPr>
+            <a:spLocks noGrp="1"/>
+          </p:cNvSpPr>
+          <p:nvPr>
+            <p:ph type="body" sz="quarter" idx="10"/>
+          </p:nvPr>
+        </p:nvSpPr>
+        <p:spPr>
+          <a:xfrm>
+            <a:off x="0" y="1"/>
+            <a:ext cx="12192000" cy="6858000"/>
+          </a:xfrm>
+          <a:prstGeom prst="rect">
+            <a:avLst/>
+          </a:prstGeom>
+        </p:spPr>
+        <p:txBody>
+          <a:bodyPr anchor="ctr">
+            <a:normAutofit/>
+          </a:bodyPr>
+          <a:lstStyle>
+            <a:lvl1pPr marL="0" indent="0" algn="ctr">
+              <a:buNone/>
+              <a:defRPr sz="5200" b="1">
+                <a:latin typeface="Times New Roman" panose="02020603050405020304" pitchFamily="18" charset="0"/>
+                <a:cs typeface="Times New Roman" panose="02020603050405020304" pitchFamily="18" charset="0"/>
+              </a:defRPr>
+            </a:lvl1pPr>
+          </a:lstStyle>
+          <a:p>
+            <a:pPr lvl="0"/>
+            <a:r>
+              <a:rPr lang="en-US" dirty="0"/>
+              <a:t>Click to edit Master text styles</a:t>
+            </a:r>
+          </a:p>
+        </p:txBody>
+      </p:sp>
+    </p:spTree>
+    <p:extLst>
+      <p:ext uri="{BB962C8B-B14F-4D97-AF65-F5344CB8AC3E}">
+        <p14:creationId xmlns:p14="http://schemas.microsoft.com/office/powerpoint/2010/main" val="3185976207"/>
+      </p:ext>
+    </p:extLst>
+  </p:cSld>
+  <p:clrMapOvr>
+    <a:masterClrMapping/>
+  </p:clrMapOvr>
+  <mc:AlternateContent xmlns:mc="http://schemas.openxmlformats.org/markup-compatibility/2006" xmlns:p14="http://schemas.microsoft.com/office/powerpoint/2010/main">
+    <mc:Choice Requires="p14">
+      <p:transition spd="med" p14:dur="700">
+        <p:fade/>
+      </p:transition>
+    </mc:Choice>
+    <mc:Fallback xmlns="">
+      <p:transition spd="med">
+        <p:fade/>
+      </p:transition>
+    </mc:Fallback>
+  </mc:AlternateContent>
+</p:sldLayout>
+</file>
+
+<file path=ppt/slideLayouts/slideLayout6.xml><?xml version="1.0" encoding="utf-8"?>
+<p:sldLayout xmlns:a="http://schemas.openxmlformats.org/drawingml/2006/main" xmlns:r="http://schemas.openxmlformats.org/officeDocument/2006/relationships" xmlns:p="http://schemas.openxmlformats.org/presentationml/2006/main" preserve="1" userDrawn="1">
   <p:cSld name="Divider">
     <p:spTree>
       <p:nvGrpSpPr>
@@ -1080,7 +1339,9 @@
     <p:sldLayoutId id="2147483654" r:id="rId1"/>
     <p:sldLayoutId id="2147483655" r:id="rId2"/>
     <p:sldLayoutId id="2147483656" r:id="rId3"/>
-    <p:sldLayoutId id="2147483657" r:id="rId4"/>
+    <p:sldLayoutId id="2147483658" r:id="rId4"/>
+    <p:sldLayoutId id="2147483659" r:id="rId5"/>
+    <p:sldLayoutId id="2147483657" r:id="rId6"/>
   </p:sldLayoutIdLst>
   <mc:AlternateContent xmlns:mc="http://schemas.openxmlformats.org/markup-compatibility/2006" xmlns:p14="http://schemas.microsoft.com/office/powerpoint/2010/main">
     <mc:Choice Requires="p14">

</xml_diff>

<commit_message>
Add Mass presentation ordering and system backup restore
</commit_message>
<xml_diff>
--- a/Storage/PowerPointTemplates/Template.pptx
+++ b/Storage/PowerPointTemplates/Template.pptx
@@ -197,7 +197,7 @@
           <a:p>
             <a:fld id="{90F44C2B-389E-664A-A050-6032A2525C12}" type="datetimeFigureOut">
               <a:rPr lang="en-AE" smtClean="0"/>
-              <a:t>30/08/2026</a:t>
+              <a:t>31/08/2026</a:t>
             </a:fld>
             <a:endParaRPr lang="en-AE"/>
           </a:p>
@@ -609,7 +609,7 @@
           <a:bodyPr anchor="ctr"/>
           <a:lstStyle>
             <a:lvl1pPr algn="ctr">
-              <a:defRPr sz="6000" b="1">
+              <a:defRPr sz="5400" b="1">
                 <a:solidFill>
                   <a:schemeClr val="accent1"/>
                 </a:solidFill>
@@ -653,11 +653,11 @@
           </a:prstGeom>
         </p:spPr>
         <p:txBody>
-          <a:bodyPr/>
+          <a:bodyPr anchor="ctr"/>
           <a:lstStyle>
             <a:lvl1pPr algn="ctr">
               <a:buNone/>
-              <a:defRPr sz="1800">
+              <a:defRPr sz="1600">
                 <a:solidFill>
                   <a:schemeClr val="accent1"/>
                 </a:solidFill>
@@ -732,7 +732,7 @@
             </a:extLst>
           </p:cNvPr>
           <p:cNvSpPr>
-            <a:spLocks noGrp="1" noRot="1" noMove="1" noResize="1" noEditPoints="1" noAdjustHandles="1" noChangeArrowheads="1" noChangeShapeType="1"/>
+            <a:spLocks/>
           </p:cNvSpPr>
           <p:nvPr>
             <p:ph type="body" sz="quarter" idx="11"/>
@@ -740,8 +740,8 @@
         </p:nvSpPr>
         <p:spPr>
           <a:xfrm>
-            <a:off x="0" y="6390042"/>
-            <a:ext cx="12192000" cy="467957"/>
+            <a:off x="0" y="6488482"/>
+            <a:ext cx="12192000" cy="369517"/>
           </a:xfrm>
           <a:prstGeom prst="rect">
             <a:avLst/>
@@ -777,7 +777,7 @@
             </a:extLst>
           </p:cNvPr>
           <p:cNvSpPr>
-            <a:spLocks noGrp="1" noRot="1" noMove="1" noResize="1" noEditPoints="1" noAdjustHandles="1" noChangeArrowheads="1" noChangeShapeType="1"/>
+            <a:spLocks/>
           </p:cNvSpPr>
           <p:nvPr>
             <p:ph type="body" sz="quarter" idx="10"/>
@@ -785,8 +785,8 @@
         </p:nvSpPr>
         <p:spPr>
           <a:xfrm>
-            <a:off x="0" y="1325564"/>
-            <a:ext cx="12192000" cy="5064478"/>
+            <a:off x="0" y="914400"/>
+            <a:ext cx="12192000" cy="5574082"/>
           </a:xfrm>
           <a:prstGeom prst="rect">
             <a:avLst/>
@@ -805,7 +805,7 @@
                 <a:spcPts val="0"/>
               </a:spcBef>
               <a:buNone/>
-              <a:defRPr sz="5200" b="1">
+              <a:defRPr sz="4800" b="1">
                 <a:latin typeface="Times New Roman" panose="02020603050405020304" pitchFamily="18" charset="0"/>
                 <a:ea typeface="Verdana" panose="020B0604030504040204" pitchFamily="34" charset="0"/>
                 <a:cs typeface="Times New Roman" panose="02020603050405020304" pitchFamily="18" charset="0"/>
@@ -831,7 +831,7 @@
             </a:extLst>
           </p:cNvPr>
           <p:cNvSpPr>
-            <a:spLocks noGrp="1" noRot="1" noMove="1" noResize="1" noEditPoints="1" noAdjustHandles="1" noChangeArrowheads="1" noChangeShapeType="1"/>
+            <a:spLocks/>
           </p:cNvSpPr>
           <p:nvPr>
             <p:ph type="title"/>
@@ -840,7 +840,7 @@
         <p:spPr>
           <a:xfrm>
             <a:off x="0" y="0"/>
-            <a:ext cx="12192000" cy="1325563"/>
+            <a:ext cx="12192000" cy="914400"/>
           </a:xfrm>
           <a:prstGeom prst="rect">
             <a:avLst/>
@@ -852,7 +852,7 @@
           </a:bodyPr>
           <a:lstStyle>
             <a:lvl1pPr algn="ctr">
-              <a:defRPr sz="6000" b="1">
+              <a:defRPr sz="5400" b="1">
                 <a:solidFill>
                   <a:schemeClr val="accent1"/>
                 </a:solidFill>
@@ -961,7 +961,7 @@
           <a:lstStyle>
             <a:lvl1pPr marL="0" indent="0" algn="ctr">
               <a:buNone/>
-              <a:defRPr sz="5200" b="1">
+              <a:defRPr sz="4800" b="1">
                 <a:latin typeface="Times New Roman" panose="02020603050405020304" pitchFamily="18" charset="0"/>
                 <a:cs typeface="Times New Roman" panose="02020603050405020304" pitchFamily="18" charset="0"/>
               </a:defRPr>
@@ -1044,8 +1044,8 @@
         </p:nvSpPr>
         <p:spPr>
           <a:xfrm>
-            <a:off x="0" y="1325564"/>
-            <a:ext cx="12192000" cy="5532436"/>
+            <a:off x="0" y="914400"/>
+            <a:ext cx="12192000" cy="5943600"/>
           </a:xfrm>
           <a:prstGeom prst="rect">
             <a:avLst/>
@@ -1064,7 +1064,7 @@
                 <a:spcPts val="0"/>
               </a:spcBef>
               <a:buNone/>
-              <a:defRPr sz="5200" b="1">
+              <a:defRPr sz="4800" b="1">
                 <a:latin typeface="Times New Roman" panose="02020603050405020304" pitchFamily="18" charset="0"/>
                 <a:ea typeface="Verdana" panose="020B0604030504040204" pitchFamily="34" charset="0"/>
                 <a:cs typeface="Times New Roman" panose="02020603050405020304" pitchFamily="18" charset="0"/>
@@ -1098,8 +1098,8 @@
         </p:nvSpPr>
         <p:spPr>
           <a:xfrm>
-            <a:off x="0" y="0"/>
-            <a:ext cx="12192000" cy="1325563"/>
+            <a:off x="0" y="1"/>
+            <a:ext cx="12192000" cy="914399"/>
           </a:xfrm>
           <a:prstGeom prst="rect">
             <a:avLst/>
@@ -1111,7 +1111,7 @@
           </a:bodyPr>
           <a:lstStyle>
             <a:lvl1pPr algn="ctr">
-              <a:defRPr sz="6000" b="1">
+              <a:defRPr sz="5400" b="1">
                 <a:solidFill>
                   <a:schemeClr val="accent1"/>
                 </a:solidFill>
@@ -1220,7 +1220,7 @@
           <a:lstStyle>
             <a:lvl1pPr marL="0" indent="0" algn="ctr">
               <a:buNone/>
-              <a:defRPr sz="5200" b="1">
+              <a:defRPr sz="4800" b="1">
                 <a:latin typeface="Times New Roman" panose="02020603050405020304" pitchFamily="18" charset="0"/>
                 <a:cs typeface="Times New Roman" panose="02020603050405020304" pitchFamily="18" charset="0"/>
               </a:defRPr>

</xml_diff>

<commit_message>
Add custom PowerPoint layouts for presentation items
</commit_message>
<xml_diff>
--- a/Storage/PowerPointTemplates/Template.pptx
+++ b/Storage/PowerPointTemplates/Template.pptx
@@ -197,7 +197,7 @@
           <a:p>
             <a:fld id="{90F44C2B-389E-664A-A050-6032A2525C12}" type="datetimeFigureOut">
               <a:rPr lang="en-AE" smtClean="0"/>
-              <a:t>31/08/2026</a:t>
+              <a:t>01/09/2026</a:t>
             </a:fld>
             <a:endParaRPr lang="en-AE"/>
           </a:p>
@@ -732,7 +732,7 @@
             </a:extLst>
           </p:cNvPr>
           <p:cNvSpPr>
-            <a:spLocks/>
+            <a:spLocks noGrp="1"/>
           </p:cNvSpPr>
           <p:nvPr>
             <p:ph type="body" sz="quarter" idx="11"/>
@@ -777,7 +777,7 @@
             </a:extLst>
           </p:cNvPr>
           <p:cNvSpPr>
-            <a:spLocks/>
+            <a:spLocks noGrp="1"/>
           </p:cNvSpPr>
           <p:nvPr>
             <p:ph type="body" sz="quarter" idx="10"/>
@@ -831,7 +831,7 @@
             </a:extLst>
           </p:cNvPr>
           <p:cNvSpPr>
-            <a:spLocks/>
+            <a:spLocks noGrp="1"/>
           </p:cNvSpPr>
           <p:nvPr>
             <p:ph type="title"/>
@@ -1302,6 +1302,682 @@
 </p:sldLayout>
 </file>
 
+<file path=ppt/slideLayouts/slideLayout7.xml><?xml version="1.0" encoding="utf-8"?>
+<p:sldLayout xmlns:a="http://schemas.openxmlformats.org/drawingml/2006/main" xmlns:r="http://schemas.openxmlformats.org/officeDocument/2006/relationships" xmlns:p="http://schemas.openxmlformats.org/presentationml/2006/main" preserve="1" userDrawn="1">
+  <p:cSld name="HC Safety">
+    <p:spTree>
+      <p:nvGrpSpPr>
+        <p:cNvPr id="1" name=""/>
+        <p:cNvGrpSpPr/>
+        <p:nvPr/>
+      </p:nvGrpSpPr>
+      <p:grpSpPr>
+        <a:xfrm>
+          <a:off x="0" y="0"/>
+          <a:ext cx="0" cy="0"/>
+          <a:chOff x="0" y="0"/>
+          <a:chExt cx="0" cy="0"/>
+        </a:xfrm>
+      </p:grpSpPr>
+      <p:sp>
+        <p:nvSpPr>
+          <p:cNvPr id="4" name="TextBox 3">
+            <a:extLst>
+              <a:ext uri="{FF2B5EF4-FFF2-40B4-BE49-F238E27FC236}">
+                <a16:creationId xmlns:a16="http://schemas.microsoft.com/office/drawing/2014/main" id="{3B1C7C45-6B92-2F0D-8CF1-7ED2C20F3D53}"/>
+              </a:ext>
+            </a:extLst>
+          </p:cNvPr>
+          <p:cNvSpPr txBox="1"/>
+          <p:nvPr userDrawn="1"/>
+        </p:nvSpPr>
+        <p:spPr>
+          <a:xfrm>
+            <a:off x="96751" y="317667"/>
+            <a:ext cx="11809312" cy="6222666"/>
+          </a:xfrm>
+          <a:prstGeom prst="rect">
+            <a:avLst/>
+          </a:prstGeom>
+          <a:noFill/>
+        </p:spPr>
+        <p:txBody>
+          <a:bodyPr wrap="square">
+            <a:spAutoFit/>
+          </a:bodyPr>
+          <a:lstStyle/>
+          <a:p>
+            <a:pPr>
+              <a:defRPr/>
+            </a:pPr>
+            <a:r>
+              <a:rPr lang="en-US" sz="2400" b="1" u="sng" dirty="0">
+                <a:latin typeface="Arial" panose="020B0604020202020204" pitchFamily="34" charset="0"/>
+                <a:cs typeface="Arial" panose="020B0604020202020204" pitchFamily="34" charset="0"/>
+              </a:rPr>
+              <a:t>Important health and safety notices:</a:t>
+            </a:r>
+          </a:p>
+          <a:p>
+            <a:pPr>
+              <a:defRPr/>
+            </a:pPr>
+            <a:endParaRPr lang="en-US" sz="1100" dirty="0">
+              <a:solidFill>
+                <a:schemeClr val="bg1"/>
+              </a:solidFill>
+              <a:latin typeface="Arial" panose="020B0604020202020204" pitchFamily="34" charset="0"/>
+              <a:cs typeface="Arial" panose="020B0604020202020204" pitchFamily="34" charset="0"/>
+            </a:endParaRPr>
+          </a:p>
+          <a:p>
+            <a:pPr>
+              <a:defRPr/>
+            </a:pPr>
+            <a:r>
+              <a:rPr lang="en-US" sz="1500" b="1" i="1" u="sng" dirty="0">
+                <a:latin typeface="Arial" panose="020B0604020202020204" pitchFamily="34" charset="0"/>
+                <a:cs typeface="Arial" panose="020B0604020202020204" pitchFamily="34" charset="0"/>
+              </a:rPr>
+              <a:t>Fire exit:</a:t>
+            </a:r>
+            <a:r>
+              <a:rPr lang="en-US" sz="1500" b="1" i="1" dirty="0">
+                <a:latin typeface="Arial" panose="020B0604020202020204" pitchFamily="34" charset="0"/>
+                <a:cs typeface="Arial" panose="020B0604020202020204" pitchFamily="34" charset="0"/>
+              </a:rPr>
+              <a:t>  	  </a:t>
+            </a:r>
+            <a:r>
+              <a:rPr lang="en-US" sz="2000" b="1" dirty="0">
+                <a:latin typeface="Arial" panose="020B0604020202020204" pitchFamily="34" charset="0"/>
+                <a:cs typeface="Arial" panose="020B0604020202020204" pitchFamily="34" charset="0"/>
+              </a:rPr>
+              <a:t>Through the foyer and on either side of the main body of </a:t>
+            </a:r>
+          </a:p>
+          <a:p>
+            <a:pPr>
+              <a:defRPr/>
+            </a:pPr>
+            <a:r>
+              <a:rPr lang="en-US" sz="2000" b="1" dirty="0">
+                <a:latin typeface="Arial" panose="020B0604020202020204" pitchFamily="34" charset="0"/>
+                <a:cs typeface="Arial" panose="020B0604020202020204" pitchFamily="34" charset="0"/>
+              </a:rPr>
+              <a:t>	  the church</a:t>
+            </a:r>
+            <a:endParaRPr lang="en-US" b="1" dirty="0">
+              <a:latin typeface="Arial" panose="020B0604020202020204" pitchFamily="34" charset="0"/>
+              <a:cs typeface="Arial" panose="020B0604020202020204" pitchFamily="34" charset="0"/>
+            </a:endParaRPr>
+          </a:p>
+          <a:p>
+            <a:pPr>
+              <a:defRPr/>
+            </a:pPr>
+            <a:endParaRPr lang="en-US" sz="1400" b="1" dirty="0">
+              <a:latin typeface="Arial" panose="020B0604020202020204" pitchFamily="34" charset="0"/>
+              <a:cs typeface="Arial" panose="020B0604020202020204" pitchFamily="34" charset="0"/>
+            </a:endParaRPr>
+          </a:p>
+          <a:p>
+            <a:pPr>
+              <a:defRPr/>
+            </a:pPr>
+            <a:r>
+              <a:rPr lang="en-US" sz="1500" b="1" i="1" u="sng" dirty="0">
+                <a:latin typeface="Arial" panose="020B0604020202020204" pitchFamily="34" charset="0"/>
+                <a:cs typeface="Arial" panose="020B0604020202020204" pitchFamily="34" charset="0"/>
+              </a:rPr>
+              <a:t>Toilets:</a:t>
+            </a:r>
+            <a:r>
+              <a:rPr lang="en-US" sz="1500" b="1" i="1" dirty="0">
+                <a:latin typeface="Arial" panose="020B0604020202020204" pitchFamily="34" charset="0"/>
+                <a:cs typeface="Arial" panose="020B0604020202020204" pitchFamily="34" charset="0"/>
+              </a:rPr>
+              <a:t>   </a:t>
+            </a:r>
+          </a:p>
+          <a:p>
+            <a:pPr marL="685794" lvl="1" indent="-228594">
+              <a:buFont typeface="Wingdings" pitchFamily="2" charset="2"/>
+              <a:buChar char="ü"/>
+              <a:defRPr/>
+            </a:pPr>
+            <a:r>
+              <a:rPr lang="en-US" sz="2000" b="1" dirty="0">
+                <a:latin typeface="Arial" panose="020B0604020202020204" pitchFamily="34" charset="0"/>
+                <a:cs typeface="Arial" panose="020B0604020202020204" pitchFamily="34" charset="0"/>
+              </a:rPr>
+              <a:t>For public on the right in the foyer.</a:t>
+            </a:r>
+          </a:p>
+          <a:p>
+            <a:pPr marL="685794" lvl="1" indent="-228594">
+              <a:buFont typeface="Wingdings" pitchFamily="2" charset="2"/>
+              <a:buChar char="ü"/>
+              <a:defRPr/>
+            </a:pPr>
+            <a:r>
+              <a:rPr lang="en-US" sz="2000" b="1" dirty="0">
+                <a:latin typeface="Arial" panose="020B0604020202020204" pitchFamily="34" charset="0"/>
+                <a:cs typeface="Arial" panose="020B0604020202020204" pitchFamily="34" charset="0"/>
+              </a:rPr>
+              <a:t>Small children must be accompanied by an adult.</a:t>
+            </a:r>
+          </a:p>
+          <a:p>
+            <a:pPr marL="685794" lvl="1" indent="-228594">
+              <a:buFont typeface="Wingdings" pitchFamily="2" charset="2"/>
+              <a:buChar char="ü"/>
+              <a:defRPr/>
+            </a:pPr>
+            <a:r>
+              <a:rPr lang="en-US" sz="2000" b="1" dirty="0">
+                <a:latin typeface="Arial" panose="020B0604020202020204" pitchFamily="34" charset="0"/>
+                <a:cs typeface="Arial" panose="020B0604020202020204" pitchFamily="34" charset="0"/>
+              </a:rPr>
+              <a:t>Sacristy toilet is for Clergy only.</a:t>
+            </a:r>
+          </a:p>
+          <a:p>
+            <a:pPr>
+              <a:defRPr/>
+            </a:pPr>
+            <a:endParaRPr lang="en-US" sz="1100" dirty="0">
+              <a:latin typeface="Arial" panose="020B0604020202020204" pitchFamily="34" charset="0"/>
+              <a:cs typeface="Arial" panose="020B0604020202020204" pitchFamily="34" charset="0"/>
+            </a:endParaRPr>
+          </a:p>
+          <a:p>
+            <a:pPr>
+              <a:defRPr/>
+            </a:pPr>
+            <a:endParaRPr lang="en-US" sz="2400" dirty="0">
+              <a:latin typeface="Arial" panose="020B0604020202020204" pitchFamily="34" charset="0"/>
+              <a:cs typeface="Arial" panose="020B0604020202020204" pitchFamily="34" charset="0"/>
+            </a:endParaRPr>
+          </a:p>
+          <a:p>
+            <a:pPr>
+              <a:defRPr/>
+            </a:pPr>
+            <a:endParaRPr lang="en-US" sz="1600" dirty="0">
+              <a:latin typeface="Arial" panose="020B0604020202020204" pitchFamily="34" charset="0"/>
+              <a:cs typeface="Arial" panose="020B0604020202020204" pitchFamily="34" charset="0"/>
+            </a:endParaRPr>
+          </a:p>
+          <a:p>
+            <a:pPr>
+              <a:defRPr/>
+            </a:pPr>
+            <a:endParaRPr lang="en-US" sz="1600" dirty="0">
+              <a:solidFill>
+                <a:schemeClr val="bg1"/>
+              </a:solidFill>
+              <a:latin typeface="Arial" panose="020B0604020202020204" pitchFamily="34" charset="0"/>
+              <a:cs typeface="Arial" panose="020B0604020202020204" pitchFamily="34" charset="0"/>
+            </a:endParaRPr>
+          </a:p>
+          <a:p>
+            <a:pPr>
+              <a:lnSpc>
+                <a:spcPct val="107000"/>
+              </a:lnSpc>
+              <a:spcAft>
+                <a:spcPts val="800"/>
+              </a:spcAft>
+              <a:defRPr/>
+            </a:pPr>
+            <a:r>
+              <a:rPr lang="en-NZ" sz="1600" kern="100" dirty="0">
+                <a:latin typeface="Arial" panose="020B0604020202020204" pitchFamily="34" charset="0"/>
+                <a:ea typeface="Aptos" panose="020B0004020202020204" pitchFamily="34" charset="0"/>
+                <a:cs typeface="Arial" panose="020B0604020202020204" pitchFamily="34" charset="0"/>
+              </a:rPr>
+              <a:t> </a:t>
+            </a:r>
+          </a:p>
+          <a:p>
+            <a:pPr>
+              <a:lnSpc>
+                <a:spcPct val="107000"/>
+              </a:lnSpc>
+              <a:spcAft>
+                <a:spcPts val="800"/>
+              </a:spcAft>
+              <a:defRPr/>
+            </a:pPr>
+            <a:endParaRPr lang="en-NZ" sz="1600" kern="100" dirty="0">
+              <a:latin typeface="Arial" panose="020B0604020202020204" pitchFamily="34" charset="0"/>
+              <a:ea typeface="Aptos" panose="020B0004020202020204" pitchFamily="34" charset="0"/>
+              <a:cs typeface="Arial" panose="020B0604020202020204" pitchFamily="34" charset="0"/>
+            </a:endParaRPr>
+          </a:p>
+          <a:p>
+            <a:pPr>
+              <a:lnSpc>
+                <a:spcPct val="107000"/>
+              </a:lnSpc>
+              <a:spcAft>
+                <a:spcPts val="800"/>
+              </a:spcAft>
+              <a:defRPr/>
+            </a:pPr>
+            <a:endParaRPr lang="en-NZ" sz="1600" kern="100" dirty="0">
+              <a:latin typeface="Arial" panose="020B0604020202020204" pitchFamily="34" charset="0"/>
+              <a:ea typeface="Aptos" panose="020B0004020202020204" pitchFamily="34" charset="0"/>
+              <a:cs typeface="Arial" panose="020B0604020202020204" pitchFamily="34" charset="0"/>
+            </a:endParaRPr>
+          </a:p>
+          <a:p>
+            <a:pPr lvl="1">
+              <a:defRPr/>
+            </a:pPr>
+            <a:endParaRPr lang="en-NZ" sz="2400" b="1" i="1" kern="100" dirty="0">
+              <a:latin typeface="Arial" panose="020B0604020202020204" pitchFamily="34" charset="0"/>
+              <a:ea typeface="Aptos" panose="020B0004020202020204" pitchFamily="34" charset="0"/>
+              <a:cs typeface="Arial" panose="020B0604020202020204" pitchFamily="34" charset="0"/>
+            </a:endParaRPr>
+          </a:p>
+          <a:p>
+            <a:pPr lvl="1">
+              <a:defRPr/>
+            </a:pPr>
+            <a:r>
+              <a:rPr lang="en-NZ" sz="2400" b="1" i="1" kern="100" dirty="0">
+                <a:latin typeface="Arial" panose="020B0604020202020204" pitchFamily="34" charset="0"/>
+                <a:ea typeface="Aptos" panose="020B0004020202020204" pitchFamily="34" charset="0"/>
+                <a:cs typeface="Arial" panose="020B0604020202020204" pitchFamily="34" charset="0"/>
+              </a:rPr>
+              <a:t>Please </a:t>
+            </a:r>
+            <a:r>
+              <a:rPr lang="en-NZ" sz="2400" b="1" i="1" kern="100" dirty="0">
+                <a:solidFill>
+                  <a:srgbClr val="FF0000"/>
+                </a:solidFill>
+                <a:latin typeface="Arial" panose="020B0604020202020204" pitchFamily="34" charset="0"/>
+                <a:ea typeface="Aptos" panose="020B0004020202020204" pitchFamily="34" charset="0"/>
+                <a:cs typeface="Arial" panose="020B0604020202020204" pitchFamily="34" charset="0"/>
+              </a:rPr>
+              <a:t>DO NOT </a:t>
+            </a:r>
+            <a:r>
+              <a:rPr lang="en-NZ" sz="2400" b="1" i="1" kern="100" dirty="0">
+                <a:latin typeface="Arial" panose="020B0604020202020204" pitchFamily="34" charset="0"/>
+                <a:ea typeface="Aptos" panose="020B0004020202020204" pitchFamily="34" charset="0"/>
+                <a:cs typeface="Arial" panose="020B0604020202020204" pitchFamily="34" charset="0"/>
+              </a:rPr>
+              <a:t>let your child /ren play on the stairs.</a:t>
+            </a:r>
+          </a:p>
+          <a:p>
+            <a:pPr lvl="1">
+              <a:defRPr/>
+            </a:pPr>
+            <a:r>
+              <a:rPr lang="en-US" altLang="en-US" sz="2400" b="1" i="1" kern="100" dirty="0">
+                <a:latin typeface="Arial" panose="020B0604020202020204" pitchFamily="34" charset="0"/>
+                <a:cs typeface="Arial" panose="020B0604020202020204" pitchFamily="34" charset="0"/>
+              </a:rPr>
+              <a:t>Please </a:t>
+            </a:r>
+            <a:r>
+              <a:rPr lang="en-US" altLang="en-US" sz="2400" b="1" i="1" kern="100" dirty="0">
+                <a:solidFill>
+                  <a:srgbClr val="FF0000"/>
+                </a:solidFill>
+                <a:latin typeface="Arial" panose="020B0604020202020204" pitchFamily="34" charset="0"/>
+                <a:cs typeface="Arial" panose="020B0604020202020204" pitchFamily="34" charset="0"/>
+              </a:rPr>
+              <a:t>TURN OFF  </a:t>
+            </a:r>
+            <a:r>
+              <a:rPr lang="en-US" altLang="en-US" sz="2400" b="1" i="1" kern="100" dirty="0">
+                <a:latin typeface="Arial" panose="020B0604020202020204" pitchFamily="34" charset="0"/>
+                <a:cs typeface="Arial" panose="020B0604020202020204" pitchFamily="34" charset="0"/>
+              </a:rPr>
+              <a:t>your cellphone.</a:t>
+            </a:r>
+            <a:endParaRPr lang="en-NZ" sz="2400" b="1" i="1" kern="100" dirty="0">
+              <a:latin typeface="Arial" panose="020B0604020202020204" pitchFamily="34" charset="0"/>
+              <a:cs typeface="Arial" panose="020B0604020202020204" pitchFamily="34" charset="0"/>
+            </a:endParaRPr>
+          </a:p>
+          <a:p>
+            <a:pPr lvl="1">
+              <a:defRPr/>
+            </a:pPr>
+            <a:r>
+              <a:rPr lang="en-NZ" sz="2400" b="1" i="1" kern="100" dirty="0">
+                <a:latin typeface="Arial" panose="020B0604020202020204" pitchFamily="34" charset="0"/>
+                <a:ea typeface="Aptos" panose="020B0004020202020204" pitchFamily="34" charset="0"/>
+                <a:cs typeface="Arial" panose="020B0604020202020204" pitchFamily="34" charset="0"/>
+              </a:rPr>
+              <a:t>Thank you. God bless.</a:t>
+            </a:r>
+          </a:p>
+        </p:txBody>
+      </p:sp>
+      <p:graphicFrame>
+        <p:nvGraphicFramePr>
+          <p:cNvPr id="5" name="Table 4">
+            <a:extLst>
+              <a:ext uri="{FF2B5EF4-FFF2-40B4-BE49-F238E27FC236}">
+                <a16:creationId xmlns:a16="http://schemas.microsoft.com/office/drawing/2014/main" id="{4F911929-7C41-FF0C-F561-9D2231F0AECB}"/>
+              </a:ext>
+            </a:extLst>
+          </p:cNvPr>
+          <p:cNvGraphicFramePr>
+            <a:graphicFrameLocks noGrp="1"/>
+          </p:cNvGraphicFramePr>
+          <p:nvPr userDrawn="1"/>
+        </p:nvGraphicFramePr>
+        <p:xfrm>
+          <a:off x="191344" y="3148642"/>
+          <a:ext cx="11809312" cy="1785668"/>
+        </p:xfrm>
+        <a:graphic>
+          <a:graphicData uri="http://schemas.openxmlformats.org/drawingml/2006/table">
+            <a:tbl>
+              <a:tblPr firstRow="1" bandRow="1">
+                <a:tableStyleId>{5C22544A-7EE6-4342-B048-85BDC9FD1C3A}</a:tableStyleId>
+              </a:tblPr>
+              <a:tblGrid>
+                <a:gridCol w="7093001">
+                  <a:extLst>
+                    <a:ext uri="{9D8B030D-6E8A-4147-A177-3AD203B41FA5}">
+                      <a16:colId xmlns:a16="http://schemas.microsoft.com/office/drawing/2014/main" val="1042179603"/>
+                    </a:ext>
+                  </a:extLst>
+                </a:gridCol>
+                <a:gridCol w="4716311">
+                  <a:extLst>
+                    <a:ext uri="{9D8B030D-6E8A-4147-A177-3AD203B41FA5}">
+                      <a16:colId xmlns:a16="http://schemas.microsoft.com/office/drawing/2014/main" val="472394721"/>
+                    </a:ext>
+                  </a:extLst>
+                </a:gridCol>
+              </a:tblGrid>
+              <a:tr h="1785668">
+                <a:tc>
+                  <a:txBody>
+                    <a:bodyPr/>
+                    <a:lstStyle/>
+                    <a:p>
+                      <a:pPr marL="216000" indent="-241200">
+                        <a:defRPr/>
+                      </a:pPr>
+                      <a:r>
+                        <a:rPr lang="en-US" sz="1500" b="1" i="1" u="sng" dirty="0">
+                          <a:solidFill>
+                            <a:sysClr val="windowText" lastClr="000000"/>
+                          </a:solidFill>
+                          <a:effectLst/>
+                          <a:latin typeface="Arial" panose="020B0604020202020204" pitchFamily="34" charset="0"/>
+                          <a:cs typeface="Arial" panose="020B0604020202020204" pitchFamily="34" charset="0"/>
+                        </a:rPr>
+                        <a:t>Access to areas:</a:t>
+                      </a:r>
+                    </a:p>
+                    <a:p>
+                      <a:pPr marL="216000" indent="-241200">
+                        <a:lnSpc>
+                          <a:spcPct val="150000"/>
+                        </a:lnSpc>
+                        <a:buFont typeface="+mj-lt"/>
+                        <a:buAutoNum type="arabicPeriod"/>
+                        <a:defRPr/>
+                      </a:pPr>
+                      <a:r>
+                        <a:rPr lang="en-US" sz="1600" b="1" dirty="0">
+                          <a:solidFill>
+                            <a:sysClr val="windowText" lastClr="000000"/>
+                          </a:solidFill>
+                          <a:effectLst/>
+                          <a:latin typeface="Arial" panose="020B0604020202020204" pitchFamily="34" charset="0"/>
+                          <a:cs typeface="Arial" panose="020B0604020202020204" pitchFamily="34" charset="0"/>
+                        </a:rPr>
+                        <a:t>First door to the sacristy is for Priests and Sacristans only</a:t>
+                      </a:r>
+                    </a:p>
+                    <a:p>
+                      <a:pPr marL="216000" indent="-241200">
+                        <a:lnSpc>
+                          <a:spcPct val="150000"/>
+                        </a:lnSpc>
+                        <a:buFont typeface="+mj-lt"/>
+                        <a:buAutoNum type="arabicPeriod"/>
+                        <a:defRPr/>
+                      </a:pPr>
+                      <a:r>
+                        <a:rPr lang="en-US" sz="1600" b="1" dirty="0">
+                          <a:solidFill>
+                            <a:sysClr val="windowText" lastClr="000000"/>
+                          </a:solidFill>
+                          <a:effectLst/>
+                          <a:latin typeface="Arial" panose="020B0604020202020204" pitchFamily="34" charset="0"/>
+                          <a:cs typeface="Arial" panose="020B0604020202020204" pitchFamily="34" charset="0"/>
+                        </a:rPr>
+                        <a:t>Back door to the sacristy is for Altar Servers and Music groups.</a:t>
+                      </a:r>
+                    </a:p>
+                    <a:p>
+                      <a:pPr marL="216000" indent="-241200">
+                        <a:lnSpc>
+                          <a:spcPct val="150000"/>
+                        </a:lnSpc>
+                        <a:buFont typeface="+mj-lt"/>
+                        <a:buAutoNum type="arabicPeriod"/>
+                        <a:defRPr/>
+                      </a:pPr>
+                      <a:r>
+                        <a:rPr lang="en-NZ" sz="1600" b="1" kern="100" dirty="0">
+                          <a:solidFill>
+                            <a:sysClr val="windowText" lastClr="000000"/>
+                          </a:solidFill>
+                          <a:effectLst/>
+                          <a:latin typeface="Arial" panose="020B0604020202020204" pitchFamily="34" charset="0"/>
+                          <a:ea typeface="Aptos" panose="020B0004020202020204" pitchFamily="34" charset="0"/>
+                          <a:cs typeface="Arial" panose="020B0604020202020204" pitchFamily="34" charset="0"/>
+                        </a:rPr>
+                        <a:t>Back room in the sacristy for flower arranging.</a:t>
+                      </a:r>
+                    </a:p>
+                    <a:p>
+                      <a:pPr marL="216000" indent="-241200">
+                        <a:lnSpc>
+                          <a:spcPct val="150000"/>
+                        </a:lnSpc>
+                        <a:buFont typeface="+mj-lt"/>
+                        <a:buAutoNum type="arabicPeriod"/>
+                        <a:defRPr/>
+                      </a:pPr>
+                      <a:r>
+                        <a:rPr lang="en-NZ" sz="1600" b="1" kern="100" dirty="0">
+                          <a:solidFill>
+                            <a:sysClr val="windowText" lastClr="000000"/>
+                          </a:solidFill>
+                          <a:effectLst/>
+                          <a:latin typeface="Arial" panose="020B0604020202020204" pitchFamily="34" charset="0"/>
+                          <a:ea typeface="Aptos" panose="020B0004020202020204" pitchFamily="34" charset="0"/>
+                          <a:cs typeface="Arial" panose="020B0604020202020204" pitchFamily="34" charset="0"/>
+                        </a:rPr>
+                        <a:t>The Vestry is reserved for the Priests to robe for Mass</a:t>
+                      </a:r>
+                      <a:endParaRPr lang="en-NZ" sz="1500" b="1" kern="100" dirty="0">
+                        <a:solidFill>
+                          <a:sysClr val="windowText" lastClr="000000"/>
+                        </a:solidFill>
+                        <a:effectLst/>
+                        <a:latin typeface="Arial" panose="020B0604020202020204" pitchFamily="34" charset="0"/>
+                        <a:ea typeface="Aptos" panose="020B0004020202020204" pitchFamily="34" charset="0"/>
+                        <a:cs typeface="Arial" panose="020B0604020202020204" pitchFamily="34" charset="0"/>
+                      </a:endParaRPr>
+                    </a:p>
+                  </a:txBody>
+                  <a:tcPr marL="121920" marR="121920" marT="60960" marB="60960">
+                    <a:solidFill>
+                      <a:schemeClr val="bg1">
+                        <a:lumMod val="85000"/>
+                      </a:schemeClr>
+                    </a:solidFill>
+                  </a:tcPr>
+                </a:tc>
+                <a:tc>
+                  <a:txBody>
+                    <a:bodyPr/>
+                    <a:lstStyle/>
+                    <a:p>
+                      <a:pPr>
+                        <a:lnSpc>
+                          <a:spcPct val="107000"/>
+                        </a:lnSpc>
+                        <a:spcAft>
+                          <a:spcPts val="600"/>
+                        </a:spcAft>
+                        <a:defRPr/>
+                      </a:pPr>
+                      <a:r>
+                        <a:rPr lang="en-NZ" sz="1500" b="1" i="1" u="sng" kern="1200" dirty="0">
+                          <a:solidFill>
+                            <a:sysClr val="windowText" lastClr="000000"/>
+                          </a:solidFill>
+                          <a:effectLst/>
+                          <a:latin typeface="Arial" panose="020B0604020202020204" pitchFamily="34" charset="0"/>
+                          <a:ea typeface="+mn-ea"/>
+                          <a:cs typeface="Arial" panose="020B0604020202020204" pitchFamily="34" charset="0"/>
+                        </a:rPr>
+                        <a:t>Health and Wellness:</a:t>
+                      </a:r>
+                    </a:p>
+                    <a:p>
+                      <a:pPr marL="228600" indent="-228600">
+                        <a:lnSpc>
+                          <a:spcPct val="107000"/>
+                        </a:lnSpc>
+                        <a:spcAft>
+                          <a:spcPts val="600"/>
+                        </a:spcAft>
+                        <a:buFont typeface="+mj-lt"/>
+                        <a:buAutoNum type="alphaLcParenR"/>
+                        <a:defRPr/>
+                      </a:pPr>
+                      <a:r>
+                        <a:rPr lang="en-NZ" sz="1600" b="1" kern="1200" dirty="0">
+                          <a:solidFill>
+                            <a:sysClr val="windowText" lastClr="000000"/>
+                          </a:solidFill>
+                          <a:effectLst/>
+                          <a:latin typeface="Arial" panose="020B0604020202020204" pitchFamily="34" charset="0"/>
+                          <a:ea typeface="+mn-ea"/>
+                          <a:cs typeface="Arial" panose="020B0604020202020204" pitchFamily="34" charset="0"/>
+                        </a:rPr>
+                        <a:t> Please stay home if you are feeling unwell.</a:t>
+                      </a:r>
+                    </a:p>
+                    <a:p>
+                      <a:pPr marL="228600" indent="-228600">
+                        <a:lnSpc>
+                          <a:spcPct val="107000"/>
+                        </a:lnSpc>
+                        <a:spcAft>
+                          <a:spcPts val="600"/>
+                        </a:spcAft>
+                        <a:buFont typeface="+mj-lt"/>
+                        <a:buAutoNum type="alphaLcParenR"/>
+                        <a:defRPr/>
+                      </a:pPr>
+                      <a:r>
+                        <a:rPr lang="en-NZ" sz="1600" b="1" kern="1200" dirty="0">
+                          <a:solidFill>
+                            <a:sysClr val="windowText" lastClr="000000"/>
+                          </a:solidFill>
+                          <a:effectLst/>
+                          <a:latin typeface="Arial" panose="020B0604020202020204" pitchFamily="34" charset="0"/>
+                          <a:ea typeface="+mn-ea"/>
+                          <a:cs typeface="Arial" panose="020B0604020202020204" pitchFamily="34" charset="0"/>
+                        </a:rPr>
+                        <a:t> Masks are optional while attending Mass.</a:t>
+                      </a:r>
+                    </a:p>
+                    <a:p>
+                      <a:pPr marL="228600" indent="-228600">
+                        <a:lnSpc>
+                          <a:spcPct val="107000"/>
+                        </a:lnSpc>
+                        <a:spcAft>
+                          <a:spcPts val="600"/>
+                        </a:spcAft>
+                        <a:buFont typeface="+mj-lt"/>
+                        <a:buAutoNum type="alphaLcParenR"/>
+                        <a:defRPr/>
+                      </a:pPr>
+                      <a:r>
+                        <a:rPr lang="en-NZ" sz="1600" b="1" kern="1200" dirty="0">
+                          <a:solidFill>
+                            <a:sysClr val="windowText" lastClr="000000"/>
+                          </a:solidFill>
+                          <a:effectLst/>
+                          <a:latin typeface="Arial" panose="020B0604020202020204" pitchFamily="34" charset="0"/>
+                          <a:ea typeface="+mn-ea"/>
+                          <a:cs typeface="Arial" panose="020B0604020202020204" pitchFamily="34" charset="0"/>
+                        </a:rPr>
+                        <a:t> Communion is only given on the hand.</a:t>
+                      </a:r>
+                    </a:p>
+                    <a:p>
+                      <a:endParaRPr lang="en-AE" sz="1500" dirty="0">
+                        <a:effectLst/>
+                      </a:endParaRPr>
+                    </a:p>
+                  </a:txBody>
+                  <a:tcPr marL="121920" marR="121920" marT="60960" marB="60960">
+                    <a:solidFill>
+                      <a:schemeClr val="bg1">
+                        <a:lumMod val="85000"/>
+                      </a:schemeClr>
+                    </a:solidFill>
+                  </a:tcPr>
+                </a:tc>
+                <a:extLst>
+                  <a:ext uri="{0D108BD9-81ED-4DB2-BD59-A6C34878D82A}">
+                    <a16:rowId xmlns:a16="http://schemas.microsoft.com/office/drawing/2014/main" val="2990046146"/>
+                  </a:ext>
+                </a:extLst>
+              </a:tr>
+            </a:tbl>
+          </a:graphicData>
+        </a:graphic>
+      </p:graphicFrame>
+    </p:spTree>
+    <p:extLst>
+      <p:ext uri="{BB962C8B-B14F-4D97-AF65-F5344CB8AC3E}">
+        <p14:creationId xmlns:p14="http://schemas.microsoft.com/office/powerpoint/2010/main" val="2964250602"/>
+      </p:ext>
+    </p:extLst>
+  </p:cSld>
+  <p:clrMapOvr>
+    <a:masterClrMapping/>
+  </p:clrMapOvr>
+  <mc:AlternateContent xmlns:mc="http://schemas.openxmlformats.org/markup-compatibility/2006" xmlns:p14="http://schemas.microsoft.com/office/powerpoint/2010/main">
+    <mc:Choice Requires="p14">
+      <p:transition spd="med" p14:dur="700">
+        <p:fade/>
+      </p:transition>
+    </mc:Choice>
+    <mc:Fallback xmlns="">
+      <p:transition spd="med">
+        <p:fade/>
+      </p:transition>
+    </mc:Fallback>
+  </mc:AlternateContent>
+</p:sldLayout>
+</file>
+
 <file path=ppt/slideMasters/slideMaster1.xml><?xml version="1.0" encoding="utf-8"?>
 <p:sldMaster xmlns:a="http://schemas.openxmlformats.org/drawingml/2006/main" xmlns:r="http://schemas.openxmlformats.org/officeDocument/2006/relationships" xmlns:p="http://schemas.openxmlformats.org/presentationml/2006/main">
   <p:cSld>
@@ -1342,6 +2018,7 @@
     <p:sldLayoutId id="2147483658" r:id="rId4"/>
     <p:sldLayoutId id="2147483659" r:id="rId5"/>
     <p:sldLayoutId id="2147483657" r:id="rId6"/>
+    <p:sldLayoutId id="2147483660" r:id="rId7"/>
   </p:sldLayoutIdLst>
   <mc:AlternateContent xmlns:mc="http://schemas.openxmlformats.org/markup-compatibility/2006" xmlns:p14="http://schemas.microsoft.com/office/powerpoint/2010/main">
     <mc:Choice Requires="p14">

</xml_diff>

<commit_message>
Apply Roboto font and preserve current UI
</commit_message>
<xml_diff>
--- a/Storage/PowerPointTemplates/Template.pptx
+++ b/Storage/PowerPointTemplates/Template.pptx
@@ -197,7 +197,7 @@
           <a:p>
             <a:fld id="{90F44C2B-389E-664A-A050-6032A2525C12}" type="datetimeFigureOut">
               <a:rPr lang="en-AE" smtClean="0"/>
-              <a:t>02/09/2026</a:t>
+              <a:t>03/09/2026</a:t>
             </a:fld>
             <a:endParaRPr lang="en-AE"/>
           </a:p>
@@ -724,51 +724,6 @@
       </p:grpSpPr>
       <p:sp>
         <p:nvSpPr>
-          <p:cNvPr id="4" name="Footer">
-            <a:extLst>
-              <a:ext uri="{FF2B5EF4-FFF2-40B4-BE49-F238E27FC236}">
-                <a16:creationId xmlns:a16="http://schemas.microsoft.com/office/drawing/2014/main" id="{07546E71-A827-033C-0C39-A29C499CAF95}"/>
-              </a:ext>
-            </a:extLst>
-          </p:cNvPr>
-          <p:cNvSpPr>
-            <a:spLocks noGrp="1"/>
-          </p:cNvSpPr>
-          <p:nvPr>
-            <p:ph type="body" sz="quarter" idx="11"/>
-          </p:nvPr>
-        </p:nvSpPr>
-        <p:spPr>
-          <a:xfrm>
-            <a:off x="0" y="912630"/>
-            <a:ext cx="12192000" cy="369517"/>
-          </a:xfrm>
-          <a:prstGeom prst="rect">
-            <a:avLst/>
-          </a:prstGeom>
-        </p:spPr>
-        <p:txBody>
-          <a:bodyPr anchor="ctr"/>
-          <a:lstStyle>
-            <a:lvl1pPr algn="ctr">
-              <a:buNone/>
-              <a:defRPr sz="1200" i="1">
-                <a:solidFill>
-                  <a:schemeClr val="accent1"/>
-                </a:solidFill>
-                <a:latin typeface="Times New Roman" panose="02020603050405020304" pitchFamily="18" charset="0"/>
-                <a:cs typeface="Times New Roman" panose="02020603050405020304" pitchFamily="18" charset="0"/>
-              </a:defRPr>
-            </a:lvl1pPr>
-          </a:lstStyle>
-          <a:p>
-            <a:pPr lvl="0"/>
-            <a:endParaRPr lang="en-AE" dirty="0"/>
-          </a:p>
-        </p:txBody>
-      </p:sp>
-      <p:sp>
-        <p:nvSpPr>
           <p:cNvPr id="11" name="Lyrics">
             <a:extLst>
               <a:ext uri="{FF2B5EF4-FFF2-40B4-BE49-F238E27FC236}">
@@ -785,8 +740,8 @@
         </p:nvSpPr>
         <p:spPr>
           <a:xfrm>
-            <a:off x="0" y="1282147"/>
-            <a:ext cx="12192000" cy="5574082"/>
+            <a:off x="0" y="1143000"/>
+            <a:ext cx="12192000" cy="5715000"/>
           </a:xfrm>
           <a:prstGeom prst="rect">
             <a:avLst/>
@@ -847,7 +802,7 @@
           </a:prstGeom>
         </p:spPr>
         <p:txBody>
-          <a:bodyPr anchor="ctr">
+          <a:bodyPr anchor="b">
             <a:normAutofit/>
           </a:bodyPr>
           <a:lstStyle>
@@ -867,6 +822,51 @@
               <a:rPr lang="en-US" dirty="0"/>
               <a:t>Click to edit Master title style</a:t>
             </a:r>
+            <a:endParaRPr lang="en-AE" dirty="0"/>
+          </a:p>
+        </p:txBody>
+      </p:sp>
+      <p:sp>
+        <p:nvSpPr>
+          <p:cNvPr id="4" name="Footer">
+            <a:extLst>
+              <a:ext uri="{FF2B5EF4-FFF2-40B4-BE49-F238E27FC236}">
+                <a16:creationId xmlns:a16="http://schemas.microsoft.com/office/drawing/2014/main" id="{07546E71-A827-033C-0C39-A29C499CAF95}"/>
+              </a:ext>
+            </a:extLst>
+          </p:cNvPr>
+          <p:cNvSpPr>
+            <a:spLocks noGrp="1"/>
+          </p:cNvSpPr>
+          <p:nvPr>
+            <p:ph type="body" sz="quarter" idx="11"/>
+          </p:nvPr>
+        </p:nvSpPr>
+        <p:spPr>
+          <a:xfrm>
+            <a:off x="0" y="864705"/>
+            <a:ext cx="12192000" cy="270124"/>
+          </a:xfrm>
+          <a:prstGeom prst="rect">
+            <a:avLst/>
+          </a:prstGeom>
+        </p:spPr>
+        <p:txBody>
+          <a:bodyPr anchor="t"/>
+          <a:lstStyle>
+            <a:lvl1pPr algn="ctr">
+              <a:buNone/>
+              <a:defRPr sz="1400" i="1">
+                <a:solidFill>
+                  <a:schemeClr val="accent1"/>
+                </a:solidFill>
+                <a:latin typeface="Times New Roman" panose="02020603050405020304" pitchFamily="18" charset="0"/>
+                <a:cs typeface="Times New Roman" panose="02020603050405020304" pitchFamily="18" charset="0"/>
+              </a:defRPr>
+            </a:lvl1pPr>
+          </a:lstStyle>
+          <a:p>
+            <a:pPr lvl="0"/>
             <a:endParaRPr lang="en-AE" dirty="0"/>
           </a:p>
         </p:txBody>

</xml_diff>